<commit_message>
Hoàn thiện hồ sơ nộp bài: bỏ mã nội bộ trong slide, sửa tham chiếu ngoài gói, thống nhất số liệu kiểm thử, đặt tác giả
Co-Authored-By: Claude Sonnet 5.5 <noreply@anthropic.com>
</commit_message>
<xml_diff>
--- a/docs/tai_lieu_nop_bai/Slide-thuyet-trinh.pptx
+++ b/docs/tai_lieu_nop_bai/Slide-thuyet-trinh.pptx
@@ -6023,7 +6023,7 @@
                 </a:solidFill>
                 <a:latin typeface="Calibri"/>
               </a:rPr>
-              <a:t>Phần mềm: trang OKR theo dõi đã cài (ADR-034) · Đề xuất, chờ xác nhận (GAP G-31)</a:t>
+              <a:t>Phần mềm: trang OKR theo dõi đã cài · Đề xuất, chờ xác nhận</a:t>
             </a:r>
           </a:p>
         </p:txBody>
@@ -7587,7 +7587,7 @@
                 </a:solidFill>
                 <a:latin typeface="Calibri"/>
               </a:rPr>
-              <a:t>Luồng tự chấm, thẩm định, phê duyệt, trả lại có lý do; khóa hồ sơ sau phê duyệt ở cả lớp nghiệp vụ và cơ sở dữ liệu; nhật ký mọi bước. Hồ sơ của Ban chỉ thẩm định được khi mọi phòng đã phê duyệt. Người thẩm định, phê duyệt lấy theo cây vị trí, là giả định cần xác nhận (GAP G-17, G-29).</a:t>
+              <a:t>Luồng tự chấm, thẩm định, phê duyệt, trả lại có lý do; khóa hồ sơ sau phê duyệt ở cả lớp nghiệp vụ và cơ sở dữ liệu; nhật ký mọi bước. Hồ sơ của Ban chỉ thẩm định được khi mọi phòng đã phê duyệt. Người thẩm định, phê duyệt lấy theo cây vị trí, là giả định cần xác nhận.</a:t>
             </a:r>
           </a:p>
         </p:txBody>
@@ -7730,7 +7730,7 @@
                 </a:solidFill>
                 <a:latin typeface="Calibri"/>
               </a:rPr>
-              <a:t>Chi tiết và căn cứ: bộ tiêu chí mục 8 · GAP G-17, G-18, G-29, G-31, G-37, G-38</a:t>
+              <a:t>Chi tiết và căn cứ: bộ tiêu chí mục 8</a:t>
             </a:r>
           </a:p>
         </p:txBody>
@@ -11260,7 +11260,7 @@
                 </a:solidFill>
                 <a:latin typeface="Calibri"/>
               </a:rPr>
-              <a:t>Nguồn: văn bản trả lời yêu cầu 3, mục 5 · ADR-011, ADR-032</a:t>
+              <a:t>Nguồn: văn bản trả lời yêu cầu 3, mục 5</a:t>
             </a:r>
           </a:p>
         </p:txBody>
@@ -11714,7 +11714,7 @@
                 </a:solidFill>
                 <a:latin typeface="Calibri"/>
               </a:rPr>
-              <a:t>Kiểm thử: 868 test đơn vị và 171 test end-to-end trên cơ sở dữ liệu thật đều đạt; cấu hình sau proxy Nginx thật đã kiểm; sao lưu và phục hồi đã chạy thử trên dữ liệu của dự án.</a:t>
+              <a:t>Kiểm thử: 898 test đơn vị và 172 test end-to-end trên cơ sở dữ liệu thật đều đạt; cấu hình sau proxy Nginx thật đã kiểm; sao lưu và phục hồi đã chạy thử trên dữ liệu của dự án.</a:t>
             </a:r>
           </a:p>
         </p:txBody>
@@ -11857,7 +11857,7 @@
                 </a:solidFill>
                 <a:latin typeface="Calibri"/>
               </a:rPr>
-              <a:t>Căn cứ: Nghị định 63/2026/NĐ-CP Điều 5.8, 6 · Quy định 342 Điều 21.6, 23 · ADR-005, ADR-007</a:t>
+              <a:t>Căn cứ: Nghị định 63/2026/NĐ-CP Điều 5.8, 6 · Quy định 342 Điều 21.6, 23</a:t>
             </a:r>
           </a:p>
         </p:txBody>
@@ -13993,7 +13993,7 @@
                 </a:solidFill>
                 <a:latin typeface="Calibri"/>
               </a:rPr>
-              <a:t>Chi tiết: văn bản trả lời yêu cầu 3, mục 7 · GAP G-08, G-12, G-26</a:t>
+              <a:t>Chi tiết: văn bản trả lời yêu cầu 3, mục 7</a:t>
             </a:r>
           </a:p>
         </p:txBody>
@@ -15127,7 +15127,7 @@
                 </a:solidFill>
                 <a:latin typeface="Calibri"/>
               </a:rPr>
-              <a:t>Văn bản đầy đủ: knowledge/deliverables · Quyết định thiết kế: knowledge/adr · Điểm chưa rõ: gap/GAP.md</a:t>
+              <a:t>Văn bản đầy đủ: văn bản trả lời, bộ tiêu chí, phương án an toàn thông tin, BRD và SRS trong thư mục hồ sơ nộp</a:t>
             </a:r>
           </a:p>
         </p:txBody>
@@ -20000,7 +20000,7 @@
                 </a:solidFill>
                 <a:latin typeface="Calibri"/>
               </a:rPr>
-              <a:t>Hồ sơ năm lấy trung bình cộng điểm các tháng đã phê duyệt (Điều 17.3), cần từ 6 tháng (Điều 11.1). Tháng nghỉ ốm, thai sản có căn cứ không tính vào trung bình (Điều 11.2). Có bảng trung bình quý và 6 tháng để theo dõi (GAP G-24).</a:t>
+              <a:t>Hồ sơ năm lấy trung bình cộng điểm các tháng đã phê duyệt (Điều 17.3), cần từ 6 tháng (Điều 11.1). Tháng nghỉ ốm, thai sản có căn cứ không tính vào trung bình (Điều 11.2). Có bảng trung bình quý và 6 tháng để theo dõi (đề xuất, chờ xác nhận).</a:t>
             </a:r>
           </a:p>
         </p:txBody>

</xml_diff>